<commit_message>
Improve readability of README.md
</commit_message>
<xml_diff>
--- a/icon.pptx
+++ b/icon.pptx
@@ -6,6 +6,7 @@
   </p:sldMasterIdLst>
   <p:sldIdLst>
     <p:sldId id="256" r:id="rId2"/>
+    <p:sldId id="258" r:id="rId3"/>
   </p:sldIdLst>
   <p:sldSz cx="3600450" cy="3600450"/>
   <p:notesSz cx="6858000" cy="9144000"/>
@@ -261,7 +262,7 @@
           <a:p>
             <a:fld id="{6B5B3B32-9917-4668-A9D7-FDCF3C496E47}" type="datetimeFigureOut">
               <a:rPr lang="en-GB" smtClean="0"/>
-              <a:t>16/06/2025</a:t>
+              <a:t>19/03/2026</a:t>
             </a:fld>
             <a:endParaRPr lang="en-GB"/>
           </a:p>
@@ -461,7 +462,7 @@
           <a:p>
             <a:fld id="{6B5B3B32-9917-4668-A9D7-FDCF3C496E47}" type="datetimeFigureOut">
               <a:rPr lang="en-GB" smtClean="0"/>
-              <a:t>16/06/2025</a:t>
+              <a:t>19/03/2026</a:t>
             </a:fld>
             <a:endParaRPr lang="en-GB"/>
           </a:p>
@@ -671,7 +672,7 @@
           <a:p>
             <a:fld id="{6B5B3B32-9917-4668-A9D7-FDCF3C496E47}" type="datetimeFigureOut">
               <a:rPr lang="en-GB" smtClean="0"/>
-              <a:t>16/06/2025</a:t>
+              <a:t>19/03/2026</a:t>
             </a:fld>
             <a:endParaRPr lang="en-GB"/>
           </a:p>
@@ -871,7 +872,7 @@
           <a:p>
             <a:fld id="{6B5B3B32-9917-4668-A9D7-FDCF3C496E47}" type="datetimeFigureOut">
               <a:rPr lang="en-GB" smtClean="0"/>
-              <a:t>16/06/2025</a:t>
+              <a:t>19/03/2026</a:t>
             </a:fld>
             <a:endParaRPr lang="en-GB"/>
           </a:p>
@@ -1147,7 +1148,7 @@
           <a:p>
             <a:fld id="{6B5B3B32-9917-4668-A9D7-FDCF3C496E47}" type="datetimeFigureOut">
               <a:rPr lang="en-GB" smtClean="0"/>
-              <a:t>16/06/2025</a:t>
+              <a:t>19/03/2026</a:t>
             </a:fld>
             <a:endParaRPr lang="en-GB"/>
           </a:p>
@@ -1415,7 +1416,7 @@
           <a:p>
             <a:fld id="{6B5B3B32-9917-4668-A9D7-FDCF3C496E47}" type="datetimeFigureOut">
               <a:rPr lang="en-GB" smtClean="0"/>
-              <a:t>16/06/2025</a:t>
+              <a:t>19/03/2026</a:t>
             </a:fld>
             <a:endParaRPr lang="en-GB"/>
           </a:p>
@@ -1830,7 +1831,7 @@
           <a:p>
             <a:fld id="{6B5B3B32-9917-4668-A9D7-FDCF3C496E47}" type="datetimeFigureOut">
               <a:rPr lang="en-GB" smtClean="0"/>
-              <a:t>16/06/2025</a:t>
+              <a:t>19/03/2026</a:t>
             </a:fld>
             <a:endParaRPr lang="en-GB"/>
           </a:p>
@@ -1972,7 +1973,7 @@
           <a:p>
             <a:fld id="{6B5B3B32-9917-4668-A9D7-FDCF3C496E47}" type="datetimeFigureOut">
               <a:rPr lang="en-GB" smtClean="0"/>
-              <a:t>16/06/2025</a:t>
+              <a:t>19/03/2026</a:t>
             </a:fld>
             <a:endParaRPr lang="en-GB"/>
           </a:p>
@@ -2085,7 +2086,7 @@
           <a:p>
             <a:fld id="{6B5B3B32-9917-4668-A9D7-FDCF3C496E47}" type="datetimeFigureOut">
               <a:rPr lang="en-GB" smtClean="0"/>
-              <a:t>16/06/2025</a:t>
+              <a:t>19/03/2026</a:t>
             </a:fld>
             <a:endParaRPr lang="en-GB"/>
           </a:p>
@@ -2398,7 +2399,7 @@
           <a:p>
             <a:fld id="{6B5B3B32-9917-4668-A9D7-FDCF3C496E47}" type="datetimeFigureOut">
               <a:rPr lang="en-GB" smtClean="0"/>
-              <a:t>16/06/2025</a:t>
+              <a:t>19/03/2026</a:t>
             </a:fld>
             <a:endParaRPr lang="en-GB"/>
           </a:p>
@@ -2687,7 +2688,7 @@
           <a:p>
             <a:fld id="{6B5B3B32-9917-4668-A9D7-FDCF3C496E47}" type="datetimeFigureOut">
               <a:rPr lang="en-GB" smtClean="0"/>
-              <a:t>16/06/2025</a:t>
+              <a:t>19/03/2026</a:t>
             </a:fld>
             <a:endParaRPr lang="en-GB"/>
           </a:p>
@@ -2930,7 +2931,7 @@
           <a:p>
             <a:fld id="{6B5B3B32-9917-4668-A9D7-FDCF3C496E47}" type="datetimeFigureOut">
               <a:rPr lang="en-GB" smtClean="0"/>
-              <a:t>16/06/2025</a:t>
+              <a:t>19/03/2026</a:t>
             </a:fld>
             <a:endParaRPr lang="en-GB"/>
           </a:p>
@@ -3512,6 +3513,194 @@
 </p:sld>
 </file>
 
+<file path=ppt/slides/slide2.xml><?xml version="1.0" encoding="utf-8"?>
+<p:sld xmlns:a="http://schemas.openxmlformats.org/drawingml/2006/main" xmlns:r="http://schemas.openxmlformats.org/officeDocument/2006/relationships" xmlns:p="http://schemas.openxmlformats.org/presentationml/2006/main">
+  <p:cSld>
+    <p:bg>
+      <p:bgPr>
+        <a:solidFill>
+          <a:srgbClr val="43B02A"/>
+        </a:solidFill>
+        <a:effectLst/>
+      </p:bgPr>
+    </p:bg>
+    <p:spTree>
+      <p:nvGrpSpPr>
+        <p:cNvPr id="1" name="">
+          <a:extLst>
+            <a:ext uri="{FF2B5EF4-FFF2-40B4-BE49-F238E27FC236}">
+              <a16:creationId xmlns:a16="http://schemas.microsoft.com/office/drawing/2014/main" id="{4563B547-779C-AAD3-0617-BBC9D660E421}"/>
+            </a:ext>
+          </a:extLst>
+        </p:cNvPr>
+        <p:cNvGrpSpPr/>
+        <p:nvPr/>
+      </p:nvGrpSpPr>
+      <p:grpSpPr>
+        <a:xfrm>
+          <a:off x="0" y="0"/>
+          <a:ext cx="0" cy="0"/>
+          <a:chOff x="0" y="0"/>
+          <a:chExt cx="0" cy="0"/>
+        </a:xfrm>
+      </p:grpSpPr>
+      <p:sp>
+        <p:nvSpPr>
+          <p:cNvPr id="4" name="文本框 3">
+            <a:extLst>
+              <a:ext uri="{FF2B5EF4-FFF2-40B4-BE49-F238E27FC236}">
+                <a16:creationId xmlns:a16="http://schemas.microsoft.com/office/drawing/2014/main" id="{D0F60838-6271-19E7-BDAB-58A7D9BFBC62}"/>
+              </a:ext>
+            </a:extLst>
+          </p:cNvPr>
+          <p:cNvSpPr txBox="1"/>
+          <p:nvPr/>
+        </p:nvSpPr>
+        <p:spPr>
+          <a:xfrm>
+            <a:off x="0" y="773901"/>
+            <a:ext cx="3600450" cy="2246769"/>
+          </a:xfrm>
+          <a:prstGeom prst="rect">
+            <a:avLst/>
+          </a:prstGeom>
+          <a:noFill/>
+        </p:spPr>
+        <p:txBody>
+          <a:bodyPr wrap="square" rtlCol="0" anchor="ctr">
+            <a:spAutoFit/>
+          </a:bodyPr>
+          <a:lstStyle/>
+          <a:p>
+            <a:pPr algn="ctr"/>
+            <a:r>
+              <a:rPr lang="en-GB" sz="6600" b="1" dirty="0">
+                <a:solidFill>
+                  <a:srgbClr val="F6EB14"/>
+                </a:solidFill>
+                <a:latin typeface="Sans Serif Collection" panose="020B0502040504020204" pitchFamily="34" charset="0"/>
+                <a:ea typeface="Sans Serif Collection" panose="020B0502040504020204" pitchFamily="34" charset="0"/>
+                <a:cs typeface="Sans Serif Collection" panose="020B0502040504020204" pitchFamily="34" charset="0"/>
+              </a:rPr>
+              <a:t>Trimix</a:t>
+            </a:r>
+          </a:p>
+          <a:p>
+            <a:pPr algn="ctr"/>
+            <a:endParaRPr lang="en-GB" sz="800" b="1" dirty="0">
+              <a:solidFill>
+                <a:srgbClr val="F6EB14"/>
+              </a:solidFill>
+              <a:latin typeface="Sans Serif Collection" panose="020B0502040504020204" pitchFamily="34" charset="0"/>
+              <a:ea typeface="Sans Serif Collection" panose="020B0502040504020204" pitchFamily="34" charset="0"/>
+              <a:cs typeface="Sans Serif Collection" panose="020B0502040504020204" pitchFamily="34" charset="0"/>
+            </a:endParaRPr>
+          </a:p>
+          <a:p>
+            <a:pPr algn="ctr"/>
+            <a:r>
+              <a:rPr lang="en-GB" sz="6600" b="1" dirty="0">
+                <a:solidFill>
+                  <a:srgbClr val="F6EB14"/>
+                </a:solidFill>
+                <a:latin typeface="Sans Serif Collection" panose="020B0502040504020204" pitchFamily="34" charset="0"/>
+                <a:ea typeface="Sans Serif Collection" panose="020B0502040504020204" pitchFamily="34" charset="0"/>
+                <a:cs typeface="Sans Serif Collection" panose="020B0502040504020204" pitchFamily="34" charset="0"/>
+              </a:rPr>
+              <a:t>Analyser</a:t>
+            </a:r>
+          </a:p>
+        </p:txBody>
+      </p:sp>
+      <p:sp>
+        <p:nvSpPr>
+          <p:cNvPr id="2" name="文本框 1">
+            <a:extLst>
+              <a:ext uri="{FF2B5EF4-FFF2-40B4-BE49-F238E27FC236}">
+                <a16:creationId xmlns:a16="http://schemas.microsoft.com/office/drawing/2014/main" id="{951A1FD7-1CBF-0B2C-0737-67D4E46C211B}"/>
+              </a:ext>
+            </a:extLst>
+          </p:cNvPr>
+          <p:cNvSpPr txBox="1"/>
+          <p:nvPr/>
+        </p:nvSpPr>
+        <p:spPr>
+          <a:xfrm>
+            <a:off x="0" y="0"/>
+            <a:ext cx="3600450" cy="400110"/>
+          </a:xfrm>
+          <a:prstGeom prst="rect">
+            <a:avLst/>
+          </a:prstGeom>
+          <a:solidFill>
+            <a:srgbClr val="F6EB14"/>
+          </a:solidFill>
+        </p:spPr>
+        <p:txBody>
+          <a:bodyPr wrap="square" rtlCol="0">
+            <a:spAutoFit/>
+          </a:bodyPr>
+          <a:lstStyle/>
+          <a:p>
+            <a:endParaRPr lang="en-GB" sz="2000" dirty="0">
+              <a:latin typeface="Calibri" panose="020F0502020204030204" pitchFamily="34" charset="0"/>
+              <a:ea typeface="Calibri" panose="020F0502020204030204" pitchFamily="34" charset="0"/>
+              <a:cs typeface="Calibri" panose="020F0502020204030204" pitchFamily="34" charset="0"/>
+            </a:endParaRPr>
+          </a:p>
+        </p:txBody>
+      </p:sp>
+      <p:sp>
+        <p:nvSpPr>
+          <p:cNvPr id="3" name="文本框 2">
+            <a:extLst>
+              <a:ext uri="{FF2B5EF4-FFF2-40B4-BE49-F238E27FC236}">
+                <a16:creationId xmlns:a16="http://schemas.microsoft.com/office/drawing/2014/main" id="{C1AD2984-F3E9-C385-8010-41C36FD7C531}"/>
+              </a:ext>
+            </a:extLst>
+          </p:cNvPr>
+          <p:cNvSpPr txBox="1"/>
+          <p:nvPr/>
+        </p:nvSpPr>
+        <p:spPr>
+          <a:xfrm>
+            <a:off x="0" y="3200340"/>
+            <a:ext cx="3600450" cy="400110"/>
+          </a:xfrm>
+          <a:prstGeom prst="rect">
+            <a:avLst/>
+          </a:prstGeom>
+          <a:solidFill>
+            <a:srgbClr val="F6EB14"/>
+          </a:solidFill>
+        </p:spPr>
+        <p:txBody>
+          <a:bodyPr wrap="square" rtlCol="0">
+            <a:spAutoFit/>
+          </a:bodyPr>
+          <a:lstStyle/>
+          <a:p>
+            <a:endParaRPr lang="en-GB" sz="2000" dirty="0">
+              <a:latin typeface="Calibri" panose="020F0502020204030204" pitchFamily="34" charset="0"/>
+              <a:ea typeface="Calibri" panose="020F0502020204030204" pitchFamily="34" charset="0"/>
+              <a:cs typeface="Calibri" panose="020F0502020204030204" pitchFamily="34" charset="0"/>
+            </a:endParaRPr>
+          </a:p>
+        </p:txBody>
+      </p:sp>
+    </p:spTree>
+    <p:extLst>
+      <p:ext uri="{BB962C8B-B14F-4D97-AF65-F5344CB8AC3E}">
+        <p14:creationId xmlns:p14="http://schemas.microsoft.com/office/powerpoint/2010/main" val="1105313185"/>
+      </p:ext>
+    </p:extLst>
+  </p:cSld>
+  <p:clrMapOvr>
+    <a:masterClrMapping/>
+  </p:clrMapOvr>
+</p:sld>
+</file>
+
 <file path=ppt/theme/theme1.xml><?xml version="1.0" encoding="utf-8"?>
 <a:theme xmlns:a="http://schemas.openxmlformats.org/drawingml/2006/main" name="Office 主题​​">
   <a:themeElements>

</xml_diff>